<commit_message>
Resuelve compatibilidad A1 y verifica IPS en pfSense actual
</commit_message>
<xml_diff>
--- a/docs/Fase_2_Desarrollo_Proyecto_APT/Evaluacion2_Avance_Semana7_2026-10-02.pptx
+++ b/docs/Fase_2_Desarrollo_Proyecto_APT/Evaluacion2_Avance_Semana7_2026-10-02.pptx
@@ -509,7 +509,7 @@
           </a:p>
           <a:p>
             <a:r>
-              <a:t>DETALLE DE TAREAS: [{"id": "A1.1", "task": "pfSense WAN/LAN", "owner": "Freddy", "planned": "17–30 ago", "start": "2026-08-17", "end": "2026-08-30", "percent": 100, "state": "Completada", "evidence": "WAN/LAN activas; reboot OK"}, {"id": "A1.2", "task": "Kernel / offloading", "owner": "Bruno", "planned": "17–30 ago", "start": "2026-08-17", "end": "2026-08-30", "percent": 100, "state": "Completada", "evidence": "9 PASS; auditoría PARTIAL", "detail": "Auditoría reejecutada el02/10 en vtnet0+vtnet1: 9 PASS,0 FAIL,3 UNSUPPORTED; PARTIAL por OID retirados."}, {"id": "A2", "task": "4 VLAN + DHCP + aislamiento", "owner": "Freddy", "planned": "31 ago–13 sep", "start": "2026-08-31", "end": "2026-09-13", "percent": 100, "state": "Completada", "evidence": "16 pruebas PASS tras reboot", "detail": "Configuración cerrada y verificada el01/10; posterior a fecha Gantt. Bloqueos muestreados TCP22 con controles positivos; no prueba de todos los protocolos. Repetición02/10trasreinicioyambosmotoreslistos:16PASS."}, {"id": "A3.1", "task": "Suricata WAN Inline IPS", "owner": "Bruno", "planned": "14–27 sep", "start": "2026-09-14", "end": "2026-09-27", "percent": 100, "state": "Completada", "evidence": "3/3 DROP + EVE correlacionado", "detail": "Alcance WAN Ethernet/vtnet0. La inspección del HTTP interno tras terminar TLS corresponde al diseño posterior A5; no se afirma inspección del payload HTTPS cifrado."}, {"id": "A3.2", "task": "Firmas ET + dropsid.conf", "owner": "Kevin", "planned": "14–27 sep", "start": "2026-09-14", "end": "2026-09-27", "percent": 100, "state": "Completada", "evidence": "26k reglas; dependencia corregida", "detail": "WAN 26628 y trunk 26629 reglas, cero fallidas. SID2017669 oficial cargado, warning et.http.PK corregido. No todas las reglas son DROP."}, {"id": "A3.3", "task": "IPS interno / trunk LAN", "owner": "Bruno", "planned": "14–27 sep", "start": "2026-09-14", "end": "2026-09-27", "percent": 100, "state": "Completada", "evidence": "HTTP200 → 3 DROP → HTTP200", "detail": "Instancia única opt2 ejecuta Netmap en parent vtnet1. Marcador benigno MGMT→DMZ descartado, EVE VLAN99 correlacionado; HTTP normal200antes/después. No valida SQLi ni inspección dentro de TLS. Probado tras reiniciar el02/10. Guard PF probado en arranque/apagado: cero marcadores escapados en el ensayo final. Caidas WAN/trunk cierran en 0,961/0,637s observados; no cierre instant?neo garantizado."}, {"id": "A4", "task": "Reputación + GeoIP WAN", "owner": "Kevin", "planned": "28 sep–11 oct", "start": "2026-09-28", "end": "2026-10-11", "percent": 100, "state": "Completada", "evidence": "4 listas/paises: 3 DROP cada uno", "detail": "Prueba 02/10: Spamhaus, FireHOL y paises RU/KP descartan tres tramas benignas por tabla. FireHOL Alias_Deny y supresion nativa RFC1918/CGNAT verificada antes de habilitar bloqueo WAN. MaxMind lookupUS; cron programado. CapacidadPF2millones. No prueba sostenidaA10 ni tr?fico remoto real desde esos paises."}, {"id": "A5", "task": "HTTPS HAProxy → DVWA", "owner": "Cristóbal", "planned": "12–25 oct", "start": "2026-10-12", "end": "2026-10-25", "percent": 0, "state": "A tiempo", "evidence": "DVWA base; frontend pendiente", "detail": "DVWA existente en DMZ responde HTTP200/login; ese provisioning no equivale a HAProxy/TLS/rate-limits configurados. HTTP público terminó en timeout esperado; A5 no validada."}, {"id": "A6", "task": "Motor KRONOS / pfctl", "owner": "Bruno", "planned": "26 oct–08 nov", "start": "2026-10-26", "end": "2026-11-08", "percent": 0, "state": "A tiempo", "evidence": "Integración aún no probada"}, {"id": "A7", "task": "Asterisk PJSIP + AMI", "owner": "Freddy", "planned": "09–22 nov", "start": "2026-11-09", "end": "2026-11-22", "percent": 0, "state": "A tiempo", "evidence": "Host preparado; AMI pendiente", "detail": "Contenedor base en VM103 running; ninguna llamada AMI/PJSIP end-to-end probada."}, {"id": "A8", "task": "Gemini Live / voz", "owner": "Bruno", "planned": "16–29 nov", "start": "2026-11-16", "end": "2026-11-29", "percent": 0, "state": "A tiempo", "evidence": "Diálogo end-to-end pendiente"}, {"id": "A9", "task": "VPN equipo / softphones", "owner": "Freddy", "planned": "23–29 nov", "start": "2026-11-23", "end": "2026-11-29", "percent": 60, "state": "A tiempo", "evidence": "SSH OK; llamada remota falta", "detail": "Estimación por hitos: configuración tailnet separada50%, conectividad administrativa10%; ACL de Admin y softphone/VoIP40% pendientes. Tailscale termina en MGMT, no en pfSense, sin acceso del equipo a Proxmox."}, {"id": "A10", "task": "QA integral / defensa", "owner": "Kevin", "planned": "30 nov–20 dic", "start": "2026-11-30", "end": "2026-12-20", "percent": 0, "state": "A tiempo", "evidence": "SQLi / rendimiento pendientes", "detail": "Kevin coordina QA; participación de todo el equipo según Gantt. Pruebas funcionales de red ejecutadas no sustituyen QA integral SOAR, SQLi y rendimiento."}]</a:t>
+              <a:t>DETALLE DE TAREAS: [{"id": "A1.1", "task": "pfSense WAN/LAN", "owner": "Freddy", "planned": "17–30 ago", "start": "2026-08-17", "end": "2026-08-30", "percent": 100, "state": "Completada", "evidence": "WAN/LAN activas; reboot OK"}, {"id": "A1.2", "task": "Kernel / offloading", "owner": "Bruno", "planned": "17–30 ago", "start": "2026-08-17", "end": "2026-08-30", "percent": 100, "state": "Completada", "evidence": "Perfil actual: 14 PASS", "detail": "pfSense2.9/FreeBSD16: 14 PASS actuales. Perfil legacy conservado separado: 9 PASS y3OID no soportados; no averia IPS. Buffers Netmap medidos2048, rings allocator bytes no slots."}, {"id": "A2", "task": "4 VLAN + DHCP + aislamiento", "owner": "Freddy", "planned": "31 ago–13 sep", "start": "2026-08-31", "end": "2026-09-13", "percent": 100, "state": "Completada", "evidence": "16 pruebas PASS tras reboot", "detail": "Configuración cerrada y verificada el01/10; posterior a fecha Gantt. Bloqueos muestreados TCP22 con controles positivos; no prueba de todos los protocolos. Repetición02/10trasreinicioyambosmotoreslistos:16PASS."}, {"id": "A3.1", "task": "Suricata WAN Inline IPS", "owner": "Bruno", "planned": "14–27 sep", "start": "2026-09-14", "end": "2026-09-27", "percent": 100, "state": "Completada", "evidence": "3/3 DROP + EVE correlacionado", "detail": "Alcance WAN Ethernet/vtnet0. La inspección del HTTP interno tras terminar TLS corresponde al diseño posterior A5; no se afirma inspección del payload HTTPS cifrado."}, {"id": "A3.2", "task": "Firmas ET + dropsid.conf", "owner": "Kevin", "planned": "14–27 sep", "start": "2026-09-14", "end": "2026-09-27", "percent": 100, "state": "Completada", "evidence": "26k reglas; dependencia corregida", "detail": "WAN 26628 y trunk 26629 reglas, cero fallidas. SID2017669 oficial cargado, warning et.http.PK corregido. No todas las reglas son DROP."}, {"id": "A3.3", "task": "IPS interno / trunk LAN", "owner": "Bruno", "planned": "14–27 sep", "start": "2026-09-14", "end": "2026-09-27", "percent": 100, "state": "Completada", "evidence": "HTTP200 → 3 DROP → HTTP200", "detail": "Instancia única opt2 ejecuta Netmap en parent vtnet1. Marcador benigno MGMT→DMZ descartado, EVE VLAN99 correlacionado; HTTP normal200antes/después. No valida SQLi ni inspección dentro de TLS. Probado tras reiniciar el02/10. Guard PF probado en arranque/apagado: cero marcadores escapados en el ensayo final. Caidas WAN/trunk cierran en 0,961/0,637s observados; no cierre instant?neo garantizado."}, {"id": "A4", "task": "Reputación + GeoIP WAN", "owner": "Kevin", "planned": "28 sep–11 oct", "start": "2026-09-28", "end": "2026-10-11", "percent": 100, "state": "Completada", "evidence": "4 listas/paises: 3 DROP cada uno", "detail": "Prueba 02/10: Spamhaus, FireHOL y paises RU/KP descartan tres tramas benignas por tabla. FireHOL Alias_Deny y supresion nativa RFC1918/CGNAT verificada antes de habilitar bloqueo WAN. MaxMind lookupUS; cron programado. CapacidadPF2millones. No prueba sostenidaA10 ni tr?fico remoto real desde esos paises."}, {"id": "A5", "task": "HTTPS HAProxy → DVWA", "owner": "Cristóbal", "planned": "12–25 oct", "start": "2026-10-12", "end": "2026-10-25", "percent": 0, "state": "A tiempo", "evidence": "DVWA base; frontend pendiente", "detail": "DVWA existente en DMZ responde HTTP200/login; ese provisioning no equivale a HAProxy/TLS/rate-limits configurados. HTTP público terminó en timeout esperado; A5 no validada."}, {"id": "A6", "task": "Motor KRONOS / pfctl", "owner": "Bruno", "planned": "26 oct–08 nov", "start": "2026-10-26", "end": "2026-11-08", "percent": 0, "state": "A tiempo", "evidence": "Integración aún no probada"}, {"id": "A7", "task": "Asterisk PJSIP + AMI", "owner": "Freddy", "planned": "09–22 nov", "start": "2026-11-09", "end": "2026-11-22", "percent": 0, "state": "A tiempo", "evidence": "Host preparado; AMI pendiente", "detail": "Contenedor base en VM103 running; ninguna llamada AMI/PJSIP end-to-end probada."}, {"id": "A8", "task": "Gemini Live / voz", "owner": "Bruno", "planned": "16–29 nov", "start": "2026-11-16", "end": "2026-11-29", "percent": 0, "state": "A tiempo", "evidence": "Diálogo end-to-end pendiente"}, {"id": "A9", "task": "VPN equipo / softphones", "owner": "Freddy", "planned": "23–29 nov", "start": "2026-11-23", "end": "2026-11-29", "percent": 60, "state": "A tiempo", "evidence": "SSH OK; llamada remota falta", "detail": "Estimación por hitos: configuración tailnet separada50%, conectividad administrativa10%; ACL de Admin y softphone/VoIP40% pendientes. Tailscale termina en MGMT, no en pfSense, sin acceso del equipo a Proxmox."}, {"id": "A10", "task": "QA integral / defensa", "owner": "Kevin", "planned": "30 nov–20 dic", "start": "2026-11-30", "end": "2026-12-20", "percent": 0, "state": "A tiempo", "evidence": "SQLi / rendimiento pendientes", "detail": "Kevin coordina QA; participación de todo el equipo según Gantt. Pruebas funcionales de red ejecutadas no sustituyen QA integral SOAR, SQLi y rendimiento."}]</a:t>
             </a:r>
           </a:p>
           <a:p>
@@ -654,7 +654,7 @@
           <a:lstStyle/>
           <a:p>
             <a:r>
-              <a:t>PRUEBAS Y ALCANCE: {"tests": [{"name": "A2 · Freddy · Redes aisladas", "expected": "4 DHCP ACK; 3 bloqueos", "obtained": "16 PASS; SSH MGMT OK", "image": "docs\\Fase_2_Desarrollo_Proyecto_APT\\EA2_Evidencias_2026-10-02\\pruebas\\ppt-a2.png"}, {"name": "A3 · Bruno / Kevin · IPS", "expected": "DROP; arranque cerrado", "obtained": "6 DROP; 0 escapes", "image": "docs\\Fase_2_Desarrollo_Proyecto_APT\\EA2_Evidencias_2026-10-02\\pruebas\\ppt-a3.png"}, {"name": "A4 - Kevin - Reputacion/GeoIP", "expected": "3 DROP por lista", "obtained": "3 DROP en cada regla", "image": "docs\\Fase_2_Desarrollo_Proyecto_APT\\EA2_Evidencias_2026-10-02\\pruebas\\ppt-a4.png"}], "pending": "HTTPS/SOAR/llamadas/IA y rendimiento. A1: 3 OID retirados; A10: pruebas prolongadas.", "sources": ["docs\\Fase_2_Desarrollo_Proyecto_APT\\Informacion_EA2\\Plan_Trabajo_Carta_Gantt.md", "docs\\Fase_2_Desarrollo_Proyecto_APT\\AVANCE_SEMANA7_2026-10-02.md", "Responsables académicos; automatización no acredita participación presencial. Pruebas fechadas sin retrofechar.", "A4 repetida02/10inclFireHOLenforcement. A1PARTIAL3OID; fail-openinicialcorregidoenguardfinal probado. Latenciafallosmedidanoesgarant?a cero. No se declara SQLi/TLS/end-to-end futurovalidado.", "WebGUI sensor interno seleccionado DMZ/vtnet1.20; generador oficial ejecuta una sola instancia en parent trunk vtnet1 para todas las VLAN. Confirmado por proceso, sockets Netmap y EVE."]}</a:t>
+              <a:t>PRUEBAS Y ALCANCE: {"tests": [{"name": "A2 · Freddy · Redes aisladas", "expected": "4 DHCP ACK; 3 bloqueos", "obtained": "16 PASS; SSH MGMT OK", "image": "docs\\Fase_2_Desarrollo_Proyecto_APT\\EA2_Evidencias_2026-10-02\\pruebas\\ppt-a2.png"}, {"name": "A3 · Bruno / Kevin · IPS", "expected": "DROP; arranque cerrado", "obtained": "6 DROP; 0 escapes", "image": "docs\\Fase_2_Desarrollo_Proyecto_APT\\EA2_Evidencias_2026-10-02\\pruebas\\ppt-a3.png"}, {"name": "A4 - Kevin - Reputacion/GeoIP", "expected": "3 DROP por lista", "obtained": "3 DROP en cada regla", "image": "docs\\Fase_2_Desarrollo_Proyecto_APT\\EA2_Evidencias_2026-10-02\\pruebas\\ppt-a4.png"}], "pending": "HTTPS/SOAR/llamadas/IA y rendimiento. A10: pruebas prolongadas.", "sources": ["docs\\Fase_2_Desarrollo_Proyecto_APT\\Informacion_EA2\\Plan_Trabajo_Carta_Gantt.md", "docs\\Fase_2_Desarrollo_Proyecto_APT\\AVANCE_SEMANA7_2026-10-02.md", "Responsables académicos; automatización no acredita participación presencial. Pruebas fechadas sin retrofechar.", "A4 repetida02/10inclFireHOLenforcement. A1 actual14PASS; legacy3OIDretirados; fail-openinicialcorregidoenguardfinal probado. Latenciafallosmedidanoesgarant?a cero. No se declara SQLi/TLS/end-to-end futurovalidado.", "WebGUI sensor interno seleccionado DMZ/vtnet1.20; generador oficial ejecuta una sola instancia en parent trunk vtnet1 para todas las VLAN. Confirmado por proceso, sockets Netmap y EVE."]}</a:t>
             </a:r>
           </a:p>
         </p:txBody>
@@ -5412,7 +5412,7 @@
               </a:defRPr>
             </a:pPr>
             <a:r>
-              <a:t>9 PASS; auditoría PARTIAL</a:t>
+              <a:t>Perfil actual: 14 PASS</a:t>
             </a:r>
           </a:p>
         </p:txBody>
@@ -16598,7 +16598,7 @@
               </a:defRPr>
             </a:pPr>
             <a:r>
-              <a:t>Falta validar: HTTPS/SOAR/llamadas/IA y rendimiento. A1: 3 OID retirados; A10: pruebas prolongadas.</a:t>
+              <a:t>Falta validar: HTTPS/SOAR/llamadas/IA y rendimiento. A10: pruebas prolongadas.</a:t>
             </a:r>
           </a:p>
         </p:txBody>

</xml_diff>